<commit_message>
feat(scripts): add verify_claims and the Ashesi deck builder, rebuild deck
scripts/verify_claims.py re-computes every quoted number independently
and prints aggregates only. scripts/build_ashesi_deck.py builds
reports/ITN_Allocation_Ashesi.pptx from the official Ashesi Presentation
Red template (scripts/ashesi_presentation_red.pptx) and the repo figures.
The rebuilt deck's speaker notes cite notebook cells; the only slide text
change is the preprocessing mean (44).
</commit_message>
<xml_diff>
--- a/reports/ITN_Allocation_Ashesi.pptx
+++ b/reports/ITN_Allocation_Ashesi.pptx
@@ -1256,7 +1256,7 @@
           </a:p>
           <a:p>
             <a:r>
-              <a:t>Sources: PROSIT1_verify.py section B (500 seeds; leave-one-region-out on region_code with the Ridge pipeline from notebook 03). Literature: Ploton et al. 2020, Nature Communications 11:4540, doi:10.1038/s41467-020-18321-y; Kattenborn et al. 2022, ISPRS Open Journal of Photogrammetry and Remote Sensing, doi:10.1016/j.ophoto.2022.100018 (up to 28% overestimation of F1-score).</a:t>
+              <a:t>Sources: notebooks/03_pipeline_leakage.ipynb, cells leak_cd12 (500 seeds) and leak_cd14 (whole region held out, via io.split_data(..., hold_out=region)). Literature: Ploton et al. 2020, Nature Communications 11:4540, doi:10.1038/s41467-020-18321-y; Kattenborn et al. 2022, ISPRS Open Journal of Photogrammetry and Remote Sensing, doi:10.1016/j.ophoto.2022.100018 (up to 28% overestimation of F1-score).</a:t>
             </a:r>
           </a:p>
         </p:txBody>
@@ -1331,7 +1331,7 @@
           </a:p>
           <a:p>
             <a:r>
-              <a:t>Sources: src/models.py compute_allocation; PROSIT1_verify.py section C (coefficient +0.0823, p = 1.7e-7; upper-to-predicted ratios 1.1976, 1.3422, 1.1623) and section E (nets per 1,000 people 8.51, 9.17, 16.02). Coverage values: notebooks/02 cell cd06 and PROSIT1_verify.py section D.</a:t>
+              <a:t>Sources: notebooks/04_allocation.ipynb cell alloc_cd11 (coefficient +0.0823, p = 1.7e-07; upper-to-expected ratios 1.198, 1.342, 1.162; nets per 1,000 people). Coverage values: notebooks/02 cell cd06 and scripts/verify_claims.py section D.</a:t>
             </a:r>
           </a:p>
         </p:txBody>
@@ -1406,7 +1406,7 @@
           </a:p>
           <a:p>
             <a:r>
-              <a:t>Sources: the 50-district schedule in reports/allocation.md reproduces exactly from notebooks/04_allocation.ipynb (cells 818b4cc5 and d30e4cb4; PROSIT1_verify.py section C checks all 50 rows). Map drawn with src/viz.plot_district_choropleth from the same allocation, zoomed to the north, with the colour bar labelled as nets (figures/c2_allocation_map.png labels it as positives per 100k by mistake). The three pre-2018 districts later split (Garu-Tempane, Savelugu-Nanton, Bunkpurugu-Yunyoo) show their total on both successor areas.</a:t>
+              <a:t>Sources: the 50-district schedule in reports/allocation.md reproduces exactly from notebooks/04_allocation.ipynb (cells alloc_cd07 and alloc_cd09; scripts/verify_claims.py section C checks all 50 rows). Map drawn with src/viz.plot_district_choropleth from the same allocation, zoomed to the north. The three pre-2018 districts later split (Garu-Tempane, Savelugu-Nanton, Bunkpurugu-Yunyoo) show their total on both successor areas.</a:t>
             </a:r>
           </a:p>
         </p:txBody>
@@ -1481,7 +1481,7 @@
           </a:p>
           <a:p>
             <a:r>
-              <a:t>Sources: gains and losses from the schedule (PROSIT1_verify.py section E); cases-per-person ranks (PROSIT1_verify.py section C: Tamale lowest of 50; Nabdam 2.02 and Bole 2.52 times their region medians). Ghana's ITN strategy: PMI Ghana Malaria Operational Plan FY2017. Tamale Teaching Hospital as the only tertiary provider for the three northern regions: https://tth.gov.gh/about</a:t>
+              <a:t>Sources: gains and losses: notebooks/04_allocation.ipynb alloc_cd09; cases-per-person ranks: alloc_cd11 (Tamale lowest of 50, Nabdam highest of 50, Bole highest in its region). Ghana's ITN strategy: PMI Ghana Malaria Operational Plan FY2017. Tamale Teaching Hospital as the only tertiary provider for the three northern regions: https://tth.gov.gh/about</a:t>
             </a:r>
           </a:p>
         </p:txBody>
@@ -1556,7 +1556,7 @@
           </a:p>
           <a:p>
             <a:r>
-              <a:t>Sources: PROSIT1_verify.py sections C and E. Savannah and North East coverage from the survey (79.05% and 62.79%; published 79.1% and 62.6%, GDHS 2022 Table 12.1). Northern coverage bounds 61.4% and 74.0%: notebooks/02 cell cd39.</a:t>
+              <a:t>Sources: notebooks/04_allocation.ipynb cell alloc_cd13, which also prints the coverage it uses (Savannah 79.1%, North East 62.8%; published 79.1% and 62.6%, GDHS 2022 Table 12.1) and the Northern cluster-bootstrap bounds 61.4% and 74.0% (as in notebooks/02 cell cd39).</a:t>
             </a:r>
           </a:p>
         </p:txBody>
@@ -1631,7 +1631,7 @@
           </a:p>
           <a:p>
             <a:r>
-              <a:t>Sources: 207 of 260 districts: PROSIT1_verify.py (map join). Test positivity and cases per person by region: PROSIT1_verify.py section E. Spraying and chemoprevention counts: PROSIT1_verify.py section E, from data/raw/northern-ghana-districts-routine-data-2014-17.xlsx (these columns are not in ghana_district_cases.csv). Campaign rules: PMI Ghana Malaria Operational Plan FY2017. Privacy: git history holds no data files and no notebook outputs (checked 2026-09-22).</a:t>
+              <a:t>Sources: 207 of 260 districts: scripts/verify_claims.py (map join). Test positivity and cases per person by region: scripts/verify_claims.py section E. Spraying and chemoprevention counts: scripts/verify_claims.py section E, from data/raw/northern-ghana-districts-routine-data-2014-17.xlsx (these columns are not in ghana_district_cases.csv). Campaign rules: PMI Ghana Malaria Operational Plan FY2017. Privacy: git history holds no data files and no notebook outputs (checked 2026-09-22).</a:t>
             </a:r>
           </a:p>
         </p:txBody>
@@ -1706,7 +1706,7 @@
           </a:p>
           <a:p>
             <a:r>
-              <a:t>Sources: 11 districts and 3,740 nets: PROSIT1_verify.py section C. 79.1% and 62.8%: survey-weighted, PROSIT1_verify.py section D. 39 of 50 districts: PROSIT1_verify.py section E. Empty ITN intervals: notebooks/02 cell cd37. No district identifier or parasitaemia: notebooks/02 cell cd06.</a:t>
+              <a:t>Sources: 11 districts, 3,740 nets, 79.1% and 62.8%: notebooks/04_allocation.ipynb alloc_cd13. 39 of 50 districts: scripts/verify_claims.py section E. Empty ITN intervals: notebooks/02 cell cd37. No district identifier or parasitaemia: notebooks/02 cell cd06.</a:t>
             </a:r>
           </a:p>
         </p:txBody>
@@ -1926,7 +1926,7 @@
           </a:p>
           <a:p>
             <a:r>
-              <a:t>Sources: regional totals are sums of the 50-district schedule in reports/allocation.md, which reproduces exactly from notebooks/04_allocation.ipynb (cells 818b4cc5, d30e4cb4; PROSIT1_verify.py section C). Nets per 1,000 people: PROSIT1_verify.py section E. 7,720 nets moved under the region-effects model: PROSIT1_verify.py sections C and E.</a:t>
+              <a:t>Sources: notebooks/04_allocation.ipynb, cell alloc_cd07 (regional totals), alloc_cd11 (nets per 1,000 people) and alloc_cd13 (7,720 nets moved under the region-effects model).</a:t>
             </a:r>
           </a:p>
         </p:txBody>
@@ -2076,7 +2076,7 @@
           </a:p>
           <a:p>
             <a:r>
-              <a:t>Sources: 17,933 households and 618 clusters: data dictionary and notebooks/02 cell cd03. 71.0% vs 66.8% (claim C-01): notebooks/01_eda.ipynb cell eda_cd05. 50 districts on 53 polygons, 207 of 260 districts without data: PROSIT1_verify.py (map join, same logic as src/viz.py). Maps: figures/b1_data_availability.png and figures/b1_district_case_rate.png from notebook 01, with their titles trimmed.</a:t>
+              <a:t>Sources: 17,933 households and 618 clusters: data dictionary and notebooks/02 cell cd03. 71.0% vs 66.8% (claim C-01): notebooks/01_eda.ipynb cell eda_cd05. 50 districts on 53 polygons, 207 of 260 districts without data: scripts/verify_claims.py (map join, same logic as src/viz.py). Maps: figures/b1_data_availability.png and figures/b1_district_case_rate.png from notebook 01, with their titles trimmed.</a:t>
             </a:r>
           </a:p>
         </p:txBody>
@@ -2226,7 +2226,7 @@
           </a:p>
           <a:p>
             <a:r>
-              <a:t>Sources: notebooks/02_distributions.ipynb cells cd31 (582 households, 20 clusters), cd33 and cd34 (15.20 vs 7.17, 2.12 times, design effect 4.50), cd37 (published ITN intervals empty, 0 of 76), cd39 (67.69% vs 67.6%). Seed spread 4.46 to 5.39 and design-based 4.18: PROSIT1_verify.py section A. Rank 10th of 16: PROSIT1_verify.py section D. Figure: figures/a4_bootstrap_ci_comparison.png, title trimmed.</a:t>
+              <a:t>Sources: notebooks/02_distributions.ipynb cells cd31 (582 households, 20 clusters), cd33 and cd34 (15.20 vs 7.17, 2.12 times, design effect 4.50), cd37 (published ITN intervals empty, 0 of 76), cd39 (67.69% vs 67.6%). Seed spread 4.46 to 5.39 and design-based 4.18: scripts/verify_claims.py section A. Rank 10th of 16: scripts/verify_claims.py section D. Figure: figures/a4_bootstrap_ci_comparison.png, title trimmed.</a:t>
             </a:r>
           </a:p>
         </p:txBody>
@@ -2301,12 +2301,7 @@
           </a:p>
           <a:p>
             <a:r>
-              <a:t>Sources: notebooks/03_pipeline_leakage.ipynb cells leak_cd04 (87,144 vs 87,356), leak_cd06 (R² 1.0000 vs 0.2618), leak_cd08. 500-seed results and leave-one-region-out: PROSIT1_verify.py section B.</a:t>
-            </a:r>
-          </a:p>
-          <a:p>
-            <a:r>
-              <a:t>Before presenting: add the 500-seed loop and the leave-one-region-out split to notebook 03 so these numbers come from a notebook cell, and correct reports/leakage_audit.md (it still quotes R² 0.49 and a 45.5% spatial effect, neither of which reproduces).</a:t>
+              <a:t>Sources: notebooks/03_pipeline_leakage.ipynb cells leak_cd04 (87,144 vs 87,356), leak_cd06 (R² 1.0000 vs 0.2618), leak_cd08 (one seed), leak_cd12 (500 seeds) and leak_cd14 (whole region held out); the table itself is leak_cd10.</a:t>
             </a:r>
           </a:p>
         </p:txBody>
@@ -7204,7 +7199,7 @@
                           </a:solidFill>
                           <a:latin typeface="Candara"/>
                         </a:rPr>
-                        <a:t>Real mechanism, negligible here: 212 cases at seed 42, 43 on average over 500 seeds</a:t>
+                        <a:t>Real mechanism, negligible here: 212 cases at seed 42, 44 on average over 500 seeds</a:t>
                       </a:r>
                     </a:p>
                   </a:txBody>

</xml_diff>

<commit_message>
feat(presentation): add the AI declaration to the closing slide
The closing slide now states that we used AI tools to help aggregate our
information and to generate the presentation from it, and points to
WORKLOG.md for how AI was used. The deck is rebuilt; no other slide text
changes.
</commit_message>
<xml_diff>
--- a/reports/ITN_Allocation_Ashesi.pptx
+++ b/reports/ITN_Allocation_Ashesi.pptx
@@ -1777,6 +1777,11 @@
           <a:p>
             <a:r>
               <a:t>Say: Thank you. Every number in this deck has its source in the speaker notes; we are happy to take questions on any of them.</a:t>
+            </a:r>
+          </a:p>
+          <a:p>
+            <a:r>
+              <a:t>The footnote is the group's AI declaration. Each member's own AI-use declaration is part of their individual reflection.</a:t>
             </a:r>
           </a:p>
         </p:txBody>
@@ -10341,6 +10346,54 @@
           </a:p>
         </p:txBody>
       </p:sp>
+      <p:sp>
+        <p:nvSpPr>
+          <p:cNvPr id="4" name="TextBox 3"/>
+          <p:cNvSpPr txBox="1"/>
+          <p:nvPr/>
+        </p:nvSpPr>
+        <p:spPr>
+          <a:xfrm>
+            <a:off x="1069848" y="5806440"/>
+            <a:ext cx="10058400" cy="640080"/>
+          </a:xfrm>
+          <a:prstGeom prst="rect">
+            <a:avLst/>
+          </a:prstGeom>
+          <a:noFill/>
+        </p:spPr>
+        <p:txBody>
+          <a:bodyPr wrap="square" anchor="t" lIns="0" rIns="0" tIns="0" bIns="0">
+            <a:spAutoFit/>
+          </a:bodyPr>
+          <a:lstStyle/>
+          <a:p>
+            <a:pPr algn="ctr">
+              <a:spcAft>
+                <a:spcPts val="600"/>
+              </a:spcAft>
+            </a:pPr>
+            <a:r>
+              <a:rPr sz="1200" b="1" i="0">
+                <a:solidFill>
+                  <a:srgbClr val="FEBA5A"/>
+                </a:solidFill>
+                <a:latin typeface="Candara"/>
+              </a:rPr>
+              <a:t>AI declaration: </a:t>
+            </a:r>
+            <a:r>
+              <a:rPr sz="1200" b="0" i="0">
+                <a:solidFill>
+                  <a:srgbClr val="FFFFFF"/>
+                </a:solidFill>
+                <a:latin typeface="Candara"/>
+              </a:rPr>
+              <a:t>we used AI tools to help aggregate our information and to generate this presentation from our aggregated information. How AI was used is logged in the project's WORKLOG.md.</a:t>
+            </a:r>
+          </a:p>
+        </p:txBody>
+      </p:sp>
     </p:spTree>
   </p:cSld>
   <p:clrMapOvr>

</xml_diff>

<commit_message>
feat(presentation): add the burden and uncertainty map slide, fix storyline wording
The course roadmap asks for one slide with two maps side by side: expected
burden and how uncertain we are. Slide 10 now shows confirmed cases per
person by district next to how far the upper 95% bound sits above the
estimate (20%, 34% and 16% by region, from alloc_cd11). Both maps come from
the existing allocation code, and an assert ties the slide text to the
computed values.

Wording fixes so the slides tell the same story as the speaking script:
slide 2 gives the reason for population within a region and calls the
regional totals a base case, slide 3 no longer claims district-level work,
slide 4 says what the rule can and cannot separate, and slide 9's title and
caption explain the positive coverage coefficient. The deck is now 16
slides, and cross-references point to slide 13.
</commit_message>
<xml_diff>
--- a/reports/ITN_Allocation_Ashesi.pptx
+++ b/reports/ITN_Allocation_Ashesi.pptx
@@ -23,6 +23,7 @@
     <p:sldId id="278" r:id="rId31"/>
     <p:sldId id="279" r:id="rId32"/>
     <p:sldId id="280" r:id="rId33"/>
+    <p:sldId id="281" r:id="rId34"/>
   </p:sldIdLst>
   <p:sldSz cx="12192000" cy="6858000"/>
   <p:notesSz cx="6858000" cy="9144000"/>
@@ -1401,12 +1402,12 @@
           <a:lstStyle/>
           <a:p>
             <a:r>
-              <a:t>Say: This is the allocation our current rule produces.</a:t>
-            </a:r>
-          </a:p>
-          <a:p>
-            <a:r>
-              <a:t>Sources: the 50-district schedule in reports/allocation.md reproduces exactly from notebooks/04_allocation.ipynb (cells alloc_cd07 and alloc_cd09; scripts/verify_claims.py section C checks all 50 rows). Map drawn with src/viz.plot_district_choropleth from the same allocation, zoomed to the north. The three pre-2018 districts later split (Garu-Tempane, Savelugu-Nanton, Bunkpurugu-Yunyoo) show their total on both successor areas.</a:t>
+              <a:t>Say: The left map shows reported burden: confirmed cases per person over 2014-17. It is highest in Upper East and Upper West and lowest across Northern Region, where the test data point to under-testing. The right map shows how sure we are: the upper end of our 95% interval sits 20% above the estimate in Northern, 34% in Upper East and 16% in Upper West. It is one number per region because coverage is. Our rule uses that upper bound, so it leans towards the region we are least sure about.</a:t>
+            </a:r>
+          </a:p>
+          <a:p>
+            <a:r>
+              <a:t>Sources: cases per person and the upper-to-expected ratios 1.198, 1.342 and 1.162: notebooks/04_allocation.ipynb cell alloc_cd11. Both maps are drawn with src/viz.plot_district_choropleth from models.compute_allocation, zoomed to the north like the allocation map. The two-map layout (burden next to uncertainty) follows the course roadmap.</a:t>
             </a:r>
           </a:p>
         </p:txBody>
@@ -1476,12 +1477,12 @@
           <a:lstStyle/>
           <a:p>
             <a:r>
-              <a:t>Say: Against a case-proportional comparator, nets move from districts with high reported cases per person to populous districts. That follows from treating everyone in a region as equally at risk. Referral bias may exist, but our data do not show it: Bolgatanga ranks only 4th of 13 in Upper East on cases per person, and Nabdam, often named as a sending district, ranks 1st.</a:t>
-            </a:r>
-          </a:p>
-          <a:p>
-            <a:r>
-              <a:t>Sources: gains and losses: notebooks/04_allocation.ipynb alloc_cd09; cases-per-person ranks: alloc_cd11 (Tamale lowest of 50, Nabdam highest of 50, Bole highest in its region). Ghana's ITN strategy: PMI Ghana Malaria Operational Plan FY2017. Tamale Teaching Hospital as the only tertiary provider for the three northern regions: https://tth.gov.gh/about</a:t>
+              <a:t>Say: This is the allocation our current rule produces.</a:t>
+            </a:r>
+          </a:p>
+          <a:p>
+            <a:r>
+              <a:t>Sources: the 50-district schedule in reports/allocation.md reproduces exactly from notebooks/04_allocation.ipynb (cells alloc_cd07 and alloc_cd09; scripts/verify_claims.py section C checks all 50 rows). Map drawn with src/viz.plot_district_choropleth from the same allocation, zoomed to the north. The three pre-2018 districts later split (Garu-Tempane, Savelugu-Nanton, Bunkpurugu-Yunyoo) show their total on both successor areas.</a:t>
             </a:r>
           </a:p>
         </p:txBody>
@@ -1551,12 +1552,12 @@
           <a:lstStyle/>
           <a:p>
             <a:r>
-              <a:t>Say: This is where we volunteer our weak points. A region-effects model, which fits the data better, moves 7,720 nets. Correcting the coverage of 11 districts moves 3,740. Lowering Northern Region's coverage gives it fewer nets, not more, because of the positive coverage coefficient.</a:t>
-            </a:r>
-          </a:p>
-          <a:p>
-            <a:r>
-              <a:t>Sources: notebooks/04_allocation.ipynb cell alloc_cd13, which also prints the coverage it uses (Savannah 79.1%, North East 62.8%; published 79.1% and 62.6%, GDHS 2022 Table 12.1) and the Northern cluster-bootstrap bounds 61.4% and 74.0% (as in notebooks/02 cell cd39).</a:t>
+              <a:t>Say: Against a case-proportional comparator, nets move from districts with high reported cases per person to populous districts. That follows from treating everyone in a region as equally at risk. Referral bias may exist, but our data do not show it: Bolgatanga ranks only 4th of 13 in Upper East on cases per person, and Nabdam, often named as a sending district, ranks 1st.</a:t>
+            </a:r>
+          </a:p>
+          <a:p>
+            <a:r>
+              <a:t>Sources: gains and losses: notebooks/04_allocation.ipynb alloc_cd09; cases-per-person ranks: alloc_cd11 (Tamale lowest of 50, Nabdam highest of 50, Bole highest in its region). Ghana's ITN strategy: PMI Ghana Malaria Operational Plan FY2017. Tamale Teaching Hospital as the only tertiary provider for the three northern regions: https://tth.gov.gh/about</a:t>
             </a:r>
           </a:p>
         </p:txBody>
@@ -1626,12 +1627,12 @@
           <a:lstStyle/>
           <a:p>
             <a:r>
-              <a:t>Say: Equity is about who the rule helps and who it cannot see.</a:t>
-            </a:r>
-          </a:p>
-          <a:p>
-            <a:r>
-              <a:t>Sources: 207 of 260 districts: scripts/verify_claims.py (map join). Test positivity and cases per person by region: scripts/verify_claims.py section E. Spraying and chemoprevention counts: scripts/verify_claims.py section E, from data/raw/northern-ghana-districts-routine-data-2014-17.xlsx (these columns are not in ghana_district_cases.csv). Campaign rules: PMI Ghana Malaria Operational Plan FY2017. Privacy: git history holds no data files and no notebook outputs (checked 2026-09-22).</a:t>
+              <a:t>Say: This is where we volunteer our weak points. A region-effects model, which fits the data better, moves 7,720 nets. Correcting the coverage of 11 districts moves 3,740. Lowering Northern Region's coverage gives it fewer nets, not more, because of the positive coverage coefficient.</a:t>
+            </a:r>
+          </a:p>
+          <a:p>
+            <a:r>
+              <a:t>Sources: notebooks/04_allocation.ipynb cell alloc_cd13, which also prints the coverage it uses (Savannah 79.1%, North East 62.8%; published 79.1% and 62.6%, GDHS 2022 Table 12.1) and the Northern cluster-bootstrap bounds 61.4% and 74.0% (as in notebooks/02 cell cd39).</a:t>
             </a:r>
           </a:p>
         </p:txBody>
@@ -1701,12 +1702,12 @@
           <a:lstStyle/>
           <a:p>
             <a:r>
-              <a:t>Say: These are the limits we know about, and what we would do before any real distribution.</a:t>
-            </a:r>
-          </a:p>
-          <a:p>
-            <a:r>
-              <a:t>Sources: 11 districts, 3,740 nets, 79.1% and 62.8%: notebooks/04_allocation.ipynb alloc_cd13. 39 of 50 districts: scripts/verify_claims.py section E. Empty ITN intervals: notebooks/02 cell cd37. No district identifier or parasitaemia: notebooks/02 cell cd06.</a:t>
+              <a:t>Say: Equity is about who the rule helps and who it cannot see.</a:t>
+            </a:r>
+          </a:p>
+          <a:p>
+            <a:r>
+              <a:t>Sources: 207 of 260 districts: scripts/verify_claims.py (map join). Test positivity and cases per person by region: scripts/verify_claims.py section E. Spraying and chemoprevention counts: scripts/verify_claims.py section E, from data/raw/northern-ghana-districts-routine-data-2014-17.xlsx (these columns are not in ghana_district_cases.csv). Campaign rules: PMI Ghana Malaria Operational Plan FY2017. Privacy: git history holds no data files and no notebook outputs (checked 2026-09-22).</a:t>
             </a:r>
           </a:p>
         </p:txBody>
@@ -1776,6 +1777,81 @@
           <a:lstStyle/>
           <a:p>
             <a:r>
+              <a:t>Say: These are the limits we know about, and what we would do before any real distribution.</a:t>
+            </a:r>
+          </a:p>
+          <a:p>
+            <a:r>
+              <a:t>Sources: 11 districts, 3,740 nets, 79.1% and 62.8%: notebooks/04_allocation.ipynb alloc_cd13. 39 of 50 districts: scripts/verify_claims.py section E. Empty ITN intervals: notebooks/02 cell cd37. No district identifier or parasitaemia: notebooks/02 cell cd06.</a:t>
+            </a:r>
+          </a:p>
+        </p:txBody>
+      </p:sp>
+      <p:sp>
+        <p:nvSpPr>
+          <p:cNvPr id="4" name="Slide Number Placeholder 3"/>
+          <p:cNvSpPr>
+            <a:spLocks noGrp="1"/>
+          </p:cNvSpPr>
+          <p:nvPr>
+            <p:ph type="sldNum" idx="5" sz="quarter"/>
+          </p:nvPr>
+        </p:nvSpPr>
+        <p:spPr/>
+      </p:sp>
+    </p:spTree>
+  </p:cSld>
+  <p:clrMapOvr>
+    <a:masterClrMapping/>
+  </p:clrMapOvr>
+</p:notes>
+</file>
+
+<file path=ppt/notesSlides/notesSlide18.xml><?xml version="1.0" encoding="utf-8"?>
+<p:notes xmlns:a="http://schemas.openxmlformats.org/drawingml/2006/main" xmlns:p="http://schemas.openxmlformats.org/presentationml/2006/main" xmlns:r="http://schemas.openxmlformats.org/officeDocument/2006/relationships">
+  <p:cSld>
+    <p:spTree>
+      <p:nvGrpSpPr>
+        <p:cNvPr id="1" name=""/>
+        <p:cNvGrpSpPr/>
+        <p:nvPr/>
+      </p:nvGrpSpPr>
+      <p:grpSpPr>
+        <a:xfrm>
+          <a:off x="0" y="0"/>
+          <a:ext cx="0" cy="0"/>
+          <a:chOff x="0" y="0"/>
+          <a:chExt cx="0" cy="0"/>
+        </a:xfrm>
+      </p:grpSpPr>
+      <p:sp>
+        <p:nvSpPr>
+          <p:cNvPr id="2" name="Slide Image Placeholder 1"/>
+          <p:cNvSpPr>
+            <a:spLocks noGrp="1"/>
+          </p:cNvSpPr>
+          <p:nvPr>
+            <p:ph type="sldImg" idx="2"/>
+          </p:nvPr>
+        </p:nvSpPr>
+        <p:spPr/>
+      </p:sp>
+      <p:sp>
+        <p:nvSpPr>
+          <p:cNvPr id="3" name="Notes Placeholder 2"/>
+          <p:cNvSpPr>
+            <a:spLocks noGrp="1"/>
+          </p:cNvSpPr>
+          <p:nvPr>
+            <p:ph type="body" idx="3" sz="quarter"/>
+          </p:nvPr>
+        </p:nvSpPr>
+        <p:spPr/>
+        <p:txBody>
+          <a:bodyPr/>
+          <a:lstStyle/>
+          <a:p>
+            <a:r>
               <a:t>Say: Thank you. Every number in this deck has its source in the speaker notes; we are happy to take questions on any of them.</a:t>
             </a:r>
           </a:p>
@@ -1926,7 +2002,7 @@
           <a:lstStyle/>
           <a:p>
             <a:r>
-              <a:t>Say: Within each region the rule allocates in proportion to population; regional totals come from our negative binomial model. Be upfront that the regional split depends on the model.</a:t>
+              <a:t>Say: Within each region the rule allocates in proportion to population, because coverage is measured once per region. The regional totals come from our negative binomial model and are our base case; be upfront that the regional split depends on the model.</a:t>
             </a:r>
           </a:p>
           <a:p>
@@ -5671,8 +5747,8 @@
         </p:nvSpPr>
         <p:spPr>
           <a:xfrm>
-            <a:off x="566928" y="4800600"/>
-            <a:ext cx="11055096" cy="914400"/>
+            <a:off x="566928" y="4663440"/>
+            <a:ext cx="11055096" cy="1188720"/>
           </a:xfrm>
           <a:prstGeom prst="rect">
             <a:avLst/>
@@ -5691,7 +5767,32 @@
               </a:spcAft>
             </a:pPr>
             <a:r>
-              <a:rPr sz="1600" b="1" i="0">
+              <a:rPr sz="1500" b="1" i="0">
+                <a:solidFill>
+                  <a:srgbClr val="AB3D3F"/>
+                </a:solidFill>
+                <a:latin typeface="Candara"/>
+              </a:rPr>
+              <a:t>Why population within a region: </a:t>
+            </a:r>
+            <a:r>
+              <a:rPr sz="1500" b="0" i="0">
+                <a:solidFill>
+                  <a:srgbClr val="262626"/>
+                </a:solidFill>
+                <a:latin typeface="Candara"/>
+              </a:rPr>
+              <a:t>net coverage is measured once per region, so our data cannot tell two districts in the same region apart.</a:t>
+            </a:r>
+          </a:p>
+          <a:p>
+            <a:pPr algn="l">
+              <a:spcAft>
+                <a:spcPts val="600"/>
+              </a:spcAft>
+            </a:pPr>
+            <a:r>
+              <a:rPr sz="1500" b="1" i="0">
                 <a:solidFill>
                   <a:srgbClr val="AB3D3F"/>
                 </a:solidFill>
@@ -5700,13 +5801,13 @@
               <a:t>How sure we are: </a:t>
             </a:r>
             <a:r>
-              <a:rPr sz="1600" b="0" i="0">
+              <a:rPr sz="1500" b="0" i="0">
                 <a:solidFill>
                   <a:srgbClr val="262626"/>
                 </a:solidFill>
                 <a:latin typeface="Candara"/>
               </a:rPr>
-              <a:t>district shares within a region are robust; the regional split is not. A better-fitting model moves 7,720 nets between regions (slide 12).</a:t>
+              <a:t>the shares within each region are robust. The regional totals are our base case: a better-fitting model moves 7,720 nets between regions (slide 13).</a:t>
             </a:r>
           </a:p>
         </p:txBody>
@@ -5971,7 +6072,7 @@
                 </a:solidFill>
                 <a:latin typeface="Candara"/>
               </a:rPr>
-              <a:t>Different ages and tests, so this is not like for like. The point is the spread: one regional figure can hide districts at very high risk. That is why we work at district level wherever the data allow.</a:t>
+              <a:t>Different ages and tests, so this is not like for like. The point is the spread: one regional figure can hide districts at very high risk. That is why we wanted district-level targeting; the next slide shows how far our data allow it.</a:t>
             </a:r>
           </a:p>
         </p:txBody>
@@ -6173,7 +6274,7 @@
         <p:spPr>
           <a:xfrm>
             <a:off x="7635240" y="1417320"/>
-            <a:ext cx="3986784" cy="3611880"/>
+            <a:ext cx="3986784" cy="4343400"/>
           </a:xfrm>
           <a:prstGeom prst="roundRect">
             <a:avLst>
@@ -6208,7 +6309,7 @@
           <a:p>
             <a:pPr algn="l">
               <a:spcAft>
-                <a:spcPts val="1000"/>
+                <a:spcPts val="800"/>
               </a:spcAft>
             </a:pPr>
             <a:r>
@@ -6224,7 +6325,7 @@
           <a:p>
             <a:pPr algn="l" marL="219456" indent="-219456">
               <a:spcAft>
-                <a:spcPts val="1000"/>
+                <a:spcPts val="800"/>
               </a:spcAft>
               <a:buClr>
                 <a:srgbClr val="AB3D3F"/>
@@ -6233,7 +6334,7 @@
               <a:buChar char="•"/>
             </a:pPr>
             <a:r>
-              <a:rPr sz="1600" b="1" i="0">
+              <a:rPr sz="1500" b="1" i="0">
                 <a:solidFill>
                   <a:srgbClr val="262626"/>
                 </a:solidFill>
@@ -6242,7 +6343,7 @@
               <a:t>Weights matter. </a:t>
             </a:r>
             <a:r>
-              <a:rPr sz="1600" b="0" i="0">
+              <a:rPr sz="1500" b="0" i="0">
                 <a:solidFill>
                   <a:srgbClr val="262626"/>
                 </a:solidFill>
@@ -6254,7 +6355,7 @@
           <a:p>
             <a:pPr algn="l" marL="219456" indent="-219456">
               <a:spcAft>
-                <a:spcPts val="1000"/>
+                <a:spcPts val="800"/>
               </a:spcAft>
               <a:buClr>
                 <a:srgbClr val="AB3D3F"/>
@@ -6263,7 +6364,7 @@
               <a:buChar char="•"/>
             </a:pPr>
             <a:r>
-              <a:rPr sz="1600" b="1" i="0">
+              <a:rPr sz="1500" b="1" i="0">
                 <a:solidFill>
                   <a:srgbClr val="262626"/>
                 </a:solidFill>
@@ -6272,7 +6373,7 @@
               <a:t>Different years. </a:t>
             </a:r>
             <a:r>
-              <a:rPr sz="1600" b="0" i="0">
+              <a:rPr sz="1500" b="0" i="0">
                 <a:solidFill>
                   <a:srgbClr val="262626"/>
                 </a:solidFill>
@@ -6284,7 +6385,7 @@
           <a:p>
             <a:pPr algn="l" marL="219456" indent="-219456">
               <a:spcAft>
-                <a:spcPts val="1000"/>
+                <a:spcPts val="800"/>
               </a:spcAft>
               <a:buClr>
                 <a:srgbClr val="AB3D3F"/>
@@ -6293,7 +6394,7 @@
               <a:buChar char="•"/>
             </a:pPr>
             <a:r>
-              <a:rPr sz="1600" b="1" i="0">
+              <a:rPr sz="1500" b="1" i="0">
                 <a:solidFill>
                   <a:srgbClr val="262626"/>
                 </a:solidFill>
@@ -6302,7 +6403,7 @@
               <a:t>Coarse coverage. </a:t>
             </a:r>
             <a:r>
-              <a:rPr sz="1600" b="0" i="0">
+              <a:rPr sz="1500" b="0" i="0">
                 <a:solidFill>
                   <a:srgbClr val="262626"/>
                 </a:solidFill>
@@ -6314,7 +6415,7 @@
           <a:p>
             <a:pPr algn="l" marL="219456" indent="-219456">
               <a:spcAft>
-                <a:spcPts val="600"/>
+                <a:spcPts val="1200"/>
               </a:spcAft>
               <a:buClr>
                 <a:srgbClr val="AB3D3F"/>
@@ -6323,7 +6424,7 @@
               <a:buChar char="•"/>
             </a:pPr>
             <a:r>
-              <a:rPr sz="1600" b="1" i="0">
+              <a:rPr sz="1500" b="1" i="0">
                 <a:solidFill>
                   <a:srgbClr val="262626"/>
                 </a:solidFill>
@@ -6332,13 +6433,38 @@
               <a:t>No district survey data. </a:t>
             </a:r>
             <a:r>
-              <a:rPr sz="1600" b="0" i="0">
+              <a:rPr sz="1500" b="0" i="0">
                 <a:solidFill>
                   <a:srgbClr val="262626"/>
                 </a:solidFill>
                 <a:latin typeface="Candara"/>
               </a:rPr>
               <a:t>The survey can rank regions, not districts.</a:t>
+            </a:r>
+          </a:p>
+          <a:p>
+            <a:pPr algn="l">
+              <a:spcAft>
+                <a:spcPts val="600"/>
+              </a:spcAft>
+            </a:pPr>
+            <a:r>
+              <a:rPr sz="1500" b="1" i="0">
+                <a:solidFill>
+                  <a:srgbClr val="AB3D3F"/>
+                </a:solidFill>
+                <a:latin typeface="Candara"/>
+              </a:rPr>
+              <a:t>So: </a:t>
+            </a:r>
+            <a:r>
+              <a:rPr sz="1500" b="0" i="0">
+                <a:solidFill>
+                  <a:srgbClr val="262626"/>
+                </a:solidFill>
+                <a:latin typeface="Candara"/>
+              </a:rPr>
+              <a:t>our rule, expected cases × the share of households without a net, can separate regions but not districts within a region.</a:t>
             </a:r>
           </a:p>
         </p:txBody>
@@ -7796,7 +7922,7 @@
           <a:lstStyle/>
           <a:p>
             <a:r>
-              <a:t>What our allocation rule actually does</a:t>
+              <a:t>What our rule does with our data</a:t>
             </a:r>
           </a:p>
         </p:txBody>
@@ -7987,7 +8113,7 @@
                 </a:solidFill>
                 <a:latin typeface="Candara"/>
               </a:rPr>
-              <a:t>Nets per 1,000 people by region, with the share of households owning a net (DHS 2022). Allocation rises with coverage, the opposite of the intent.</a:t>
+              <a:t>Nets per 1,000 people by region, with the share of households owning a net (DHS 2022). Upper East has the highest coverage and the most nets per person: the coefficient reflects region, not the effect of nets, so the regional split is uncertain (slide 13).</a:t>
             </a:r>
           </a:p>
         </p:txBody>
@@ -8001,6 +8127,243 @@
 </file>
 
 <file path=ppt/slides/slide19.xml><?xml version="1.0" encoding="utf-8"?>
+<p:sld xmlns:a="http://schemas.openxmlformats.org/drawingml/2006/main" xmlns:p="http://schemas.openxmlformats.org/presentationml/2006/main" xmlns:r="http://schemas.openxmlformats.org/officeDocument/2006/relationships">
+  <p:cSld>
+    <p:spTree>
+      <p:nvGrpSpPr>
+        <p:cNvPr id="1" name=""/>
+        <p:cNvGrpSpPr/>
+        <p:nvPr/>
+      </p:nvGrpSpPr>
+      <p:grpSpPr/>
+      <p:sp>
+        <p:nvSpPr>
+          <p:cNvPr id="2" name="Text Placeholder 1"/>
+          <p:cNvSpPr>
+            <a:spLocks noGrp="1"/>
+          </p:cNvSpPr>
+          <p:nvPr>
+            <p:ph type="body" idx="11" sz="quarter"/>
+          </p:nvPr>
+        </p:nvSpPr>
+        <p:spPr>
+          <a:xfrm>
+            <a:off x="571500" y="571500"/>
+            <a:ext cx="11055096" cy="737700"/>
+          </a:xfrm>
+        </p:spPr>
+        <p:txBody>
+          <a:bodyPr/>
+          <a:lstStyle/>
+          <a:p>
+            <a:r>
+              <a:rPr sz="3000"/>
+              <a:t>Where the need looks highest, and how sure we are</a:t>
+            </a:r>
+          </a:p>
+        </p:txBody>
+      </p:sp>
+      <p:pic>
+        <p:nvPicPr>
+          <p:cNvPr id="3" name="Picture 2" descr="burden_map.png"/>
+          <p:cNvPicPr>
+            <a:picLocks noChangeAspect="1"/>
+          </p:cNvPicPr>
+          <p:nvPr/>
+        </p:nvPicPr>
+        <p:blipFill>
+          <a:blip r:embed="rId2"/>
+          <a:stretch>
+            <a:fillRect/>
+          </a:stretch>
+        </p:blipFill>
+        <p:spPr>
+          <a:xfrm>
+            <a:off x="1524535" y="1325880"/>
+            <a:ext cx="3479744" cy="3474720"/>
+          </a:xfrm>
+          <a:prstGeom prst="rect">
+            <a:avLst/>
+          </a:prstGeom>
+        </p:spPr>
+      </p:pic>
+      <p:sp>
+        <p:nvSpPr>
+          <p:cNvPr id="4" name="TextBox 3"/>
+          <p:cNvSpPr txBox="1"/>
+          <p:nvPr/>
+        </p:nvSpPr>
+        <p:spPr>
+          <a:xfrm>
+            <a:off x="566928" y="4892040"/>
+            <a:ext cx="5394960" cy="548640"/>
+          </a:xfrm>
+          <a:prstGeom prst="rect">
+            <a:avLst/>
+          </a:prstGeom>
+          <a:noFill/>
+        </p:spPr>
+        <p:txBody>
+          <a:bodyPr wrap="square" anchor="t" lIns="0" rIns="0" tIns="0" bIns="0">
+            <a:spAutoFit/>
+          </a:bodyPr>
+          <a:lstStyle/>
+          <a:p>
+            <a:pPr algn="l">
+              <a:spcAft>
+                <a:spcPts val="600"/>
+              </a:spcAft>
+            </a:pPr>
+            <a:r>
+              <a:rPr sz="1200" b="1" i="0">
+                <a:solidFill>
+                  <a:srgbClr val="262626"/>
+                </a:solidFill>
+                <a:latin typeface="Candara"/>
+              </a:rPr>
+              <a:t>Reported burden. </a:t>
+            </a:r>
+            <a:r>
+              <a:rPr sz="1200" b="0" i="0">
+                <a:solidFill>
+                  <a:srgbClr val="262626"/>
+                </a:solidFill>
+                <a:latin typeface="Candara"/>
+              </a:rPr>
+              <a:t>Confirmed cases per person, 2014-17: highest in Upper East and Upper West, lowest across Northern Region. Grey areas have no case data of their own.</a:t>
+            </a:r>
+          </a:p>
+        </p:txBody>
+      </p:sp>
+      <p:pic>
+        <p:nvPicPr>
+          <p:cNvPr id="5" name="Picture 4" descr="uncertainty_map.png"/>
+          <p:cNvPicPr>
+            <a:picLocks noChangeAspect="1"/>
+          </p:cNvPicPr>
+          <p:nvPr/>
+        </p:nvPicPr>
+        <p:blipFill>
+          <a:blip r:embed="rId3"/>
+          <a:stretch>
+            <a:fillRect/>
+          </a:stretch>
+        </p:blipFill>
+        <p:spPr>
+          <a:xfrm>
+            <a:off x="7184671" y="1325880"/>
+            <a:ext cx="3479744" cy="3474720"/>
+          </a:xfrm>
+          <a:prstGeom prst="rect">
+            <a:avLst/>
+          </a:prstGeom>
+        </p:spPr>
+      </p:pic>
+      <p:sp>
+        <p:nvSpPr>
+          <p:cNvPr id="6" name="TextBox 5"/>
+          <p:cNvSpPr txBox="1"/>
+          <p:nvPr/>
+        </p:nvSpPr>
+        <p:spPr>
+          <a:xfrm>
+            <a:off x="6227064" y="4892040"/>
+            <a:ext cx="5394960" cy="548640"/>
+          </a:xfrm>
+          <a:prstGeom prst="rect">
+            <a:avLst/>
+          </a:prstGeom>
+          <a:noFill/>
+        </p:spPr>
+        <p:txBody>
+          <a:bodyPr wrap="square" anchor="t" lIns="0" rIns="0" tIns="0" bIns="0">
+            <a:spAutoFit/>
+          </a:bodyPr>
+          <a:lstStyle/>
+          <a:p>
+            <a:pPr algn="l">
+              <a:spcAft>
+                <a:spcPts val="600"/>
+              </a:spcAft>
+            </a:pPr>
+            <a:r>
+              <a:rPr sz="1200" b="1" i="0">
+                <a:solidFill>
+                  <a:srgbClr val="262626"/>
+                </a:solidFill>
+                <a:latin typeface="Candara"/>
+              </a:rPr>
+              <a:t>How sure we are. </a:t>
+            </a:r>
+            <a:r>
+              <a:rPr sz="1200" b="0" i="0">
+                <a:solidFill>
+                  <a:srgbClr val="262626"/>
+                </a:solidFill>
+                <a:latin typeface="Candara"/>
+              </a:rPr>
+              <a:t>Our upper bound sits 20% above the estimate in Northern, 34% in Upper East and 16% in Upper West: one number per region, because coverage is.</a:t>
+            </a:r>
+          </a:p>
+        </p:txBody>
+      </p:sp>
+      <p:sp>
+        <p:nvSpPr>
+          <p:cNvPr id="7" name="TextBox 6"/>
+          <p:cNvSpPr txBox="1"/>
+          <p:nvPr/>
+        </p:nvSpPr>
+        <p:spPr>
+          <a:xfrm>
+            <a:off x="566928" y="5504688"/>
+            <a:ext cx="11055096" cy="365760"/>
+          </a:xfrm>
+          <a:prstGeom prst="rect">
+            <a:avLst/>
+          </a:prstGeom>
+          <a:noFill/>
+        </p:spPr>
+        <p:txBody>
+          <a:bodyPr wrap="square" anchor="t" lIns="0" rIns="0" tIns="0" bIns="0">
+            <a:spAutoFit/>
+          </a:bodyPr>
+          <a:lstStyle/>
+          <a:p>
+            <a:pPr algn="l">
+              <a:spcAft>
+                <a:spcPts val="600"/>
+              </a:spcAft>
+            </a:pPr>
+            <a:r>
+              <a:rPr sz="1400" b="1" i="0">
+                <a:solidFill>
+                  <a:srgbClr val="AB3D3F"/>
+                </a:solidFill>
+                <a:latin typeface="Candara"/>
+              </a:rPr>
+              <a:t>Takeaway: </a:t>
+            </a:r>
+            <a:r>
+              <a:rPr sz="1400" b="0" i="0">
+                <a:solidFill>
+                  <a:srgbClr val="262626"/>
+                </a:solidFill>
+                <a:latin typeface="Candara"/>
+              </a:rPr>
+              <a:t>the rule uses the upper bound, so it leans towards the region we are least sure about.</a:t>
+            </a:r>
+          </a:p>
+        </p:txBody>
+      </p:sp>
+    </p:spTree>
+  </p:cSld>
+  <p:clrMapOvr>
+    <a:masterClrMapping/>
+  </p:clrMapOvr>
+</p:sld>
+</file>
+
+<file path=ppt/slides/slide20.xml><?xml version="1.0" encoding="utf-8"?>
 <p:sld xmlns:a="http://schemas.openxmlformats.org/drawingml/2006/main" xmlns:p="http://schemas.openxmlformats.org/presentationml/2006/main" xmlns:r="http://schemas.openxmlformats.org/officeDocument/2006/relationships">
   <p:cSld>
     <p:spTree>
@@ -8227,7 +8590,7 @@
 </p:sld>
 </file>
 
-<file path=ppt/slides/slide20.xml><?xml version="1.0" encoding="utf-8"?>
+<file path=ppt/slides/slide21.xml><?xml version="1.0" encoding="utf-8"?>
 <p:sld xmlns:a="http://schemas.openxmlformats.org/drawingml/2006/main" xmlns:p="http://schemas.openxmlformats.org/presentationml/2006/main" xmlns:r="http://schemas.openxmlformats.org/officeDocument/2006/relationships">
   <p:cSld>
     <p:spTree>
@@ -8456,7 +8819,7 @@
 </p:sld>
 </file>
 
-<file path=ppt/slides/slide21.xml><?xml version="1.0" encoding="utf-8"?>
+<file path=ppt/slides/slide22.xml><?xml version="1.0" encoding="utf-8"?>
 <p:sld xmlns:a="http://schemas.openxmlformats.org/drawingml/2006/main" xmlns:p="http://schemas.openxmlformats.org/presentationml/2006/main" xmlns:r="http://schemas.openxmlformats.org/officeDocument/2006/relationships">
   <p:cSld>
     <p:spTree>
@@ -9536,7 +9899,7 @@
 </p:sld>
 </file>
 
-<file path=ppt/slides/slide22.xml><?xml version="1.0" encoding="utf-8"?>
+<file path=ppt/slides/slide23.xml><?xml version="1.0" encoding="utf-8"?>
 <p:sld xmlns:a="http://schemas.openxmlformats.org/drawingml/2006/main" xmlns:p="http://schemas.openxmlformats.org/presentationml/2006/main" xmlns:r="http://schemas.openxmlformats.org/officeDocument/2006/relationships">
   <p:cSld>
     <p:spTree>
@@ -9945,7 +10308,7 @@
 </p:sld>
 </file>
 
-<file path=ppt/slides/slide23.xml><?xml version="1.0" encoding="utf-8"?>
+<file path=ppt/slides/slide24.xml><?xml version="1.0" encoding="utf-8"?>
 <p:sld xmlns:a="http://schemas.openxmlformats.org/drawingml/2006/main" xmlns:p="http://schemas.openxmlformats.org/presentationml/2006/main" xmlns:r="http://schemas.openxmlformats.org/officeDocument/2006/relationships">
   <p:cSld>
     <p:spTree>
@@ -10275,7 +10638,7 @@
 </p:sld>
 </file>
 
-<file path=ppt/slides/slide24.xml><?xml version="1.0" encoding="utf-8"?>
+<file path=ppt/slides/slide25.xml><?xml version="1.0" encoding="utf-8"?>
 <p:sld xmlns:a="http://schemas.openxmlformats.org/drawingml/2006/main" xmlns:p="http://schemas.openxmlformats.org/presentationml/2006/main" xmlns:r="http://schemas.openxmlformats.org/officeDocument/2006/relationships">
   <p:cSld>
     <p:spTree>

</xml_diff>

<commit_message>
feat(presentation): write the allocation rule on slide 9 as math
A teammate asked for the rule in mathematical form, read out in words during
the talk. Slide 9 now shows the negative binomial mean with its population
offset, the weight as the upper confidence bound times the coverage gap, and
Hamilton's apportionment to exactly 50,000 nets, with a key that names the
unit, target and metric the brief's rubric asks for. The speaker notes read
each line in plain words. The builder gains subscript support for this.
</commit_message>
<xml_diff>
--- a/reports/ITN_Allocation_Ashesi.pptx
+++ b/reports/ITN_Allocation_Ashesi.pptx
@@ -1327,12 +1327,17 @@
           <a:lstStyle/>
           <a:p>
             <a:r>
-              <a:t>Say: Because coverage is a single regional number, the model can only tell regions apart, so within a region every district gets the same nets per person. The coverage coefficient is positive because nets went where malaria was worst, and coverage is from 2022 while cases are from 2014-17, so it cannot be read as a protective effect.</a:t>
-            </a:r>
-          </a:p>
-          <a:p>
-            <a:r>
-              <a:t>Sources: notebooks/04_allocation.ipynb cell alloc_cd11 (coefficient +0.0823, p = 1.7e-07; upper-to-expected ratios 1.198, 1.342, 1.162; nets per 1,000 people). Coverage values: notebooks/02 cell cd06 and scripts/verify_claims.py section D.</a:t>
+              <a:t>Say: The slide writes the rule as math; say it in words. Line one: expected confirmed cases grow in proportion to population and depend on the region's net coverage (a negative binomial model with a population offset). Line two: each district's weight is the cautious upper end of its expected cases times the share of homes without a net. Line three: Hamilton's largest-remainder method turns the weights into exactly 50,000 whole nets. Then: because coverage is one number per region, inside a region nets follow population; the upper bound adds one multiplier per region; and the coverage coefficient is positive because nets went where malaria was worst, so the split between regions is uncertain.</a:t>
+            </a:r>
+          </a:p>
+          <a:p>
+            <a:r>
+              <a:t>Symbols: i = district (the unit); mu_i = expected confirmed cases, 2014-17 (the target); w_i = allocation weight (the metric); pop_i = population; c_i = % of homes owning a net in i's region (DHS 2022); U_i = upper 95% confidence bound for mu_i; q_i = exact share; A_i = nets.</a:t>
+            </a:r>
+          </a:p>
+          <a:p>
+            <a:r>
+              <a:t>Sources: notebooks/04_allocation.ipynb cells alloc_cd05 (alpha 0.2677) and alloc_cd11 (beta_1 = +0.0823, p = 1.7e-07; U_i / mu_i = 1.198, 1.342, 1.162; nets per 1,000 people); src/models.py compute_allocation and hamilton. Coverage values: notebooks/02 cell cd06 and scripts/verify_claims.py section D.</a:t>
             </a:r>
           </a:p>
         </p:txBody>
@@ -7935,8 +7940,8 @@
         </p:nvSpPr>
         <p:spPr>
           <a:xfrm>
-            <a:off x="566928" y="1417320"/>
-            <a:ext cx="5486400" cy="4389120"/>
+            <a:off x="566928" y="1325880"/>
+            <a:ext cx="6263640" cy="4572000"/>
           </a:xfrm>
           <a:prstGeom prst="rect">
             <a:avLst/>
@@ -7955,29 +7960,518 @@
               </a:spcAft>
             </a:pPr>
             <a:r>
-              <a:rPr sz="1800" b="1" i="0">
+              <a:rPr sz="1700" b="1" i="0">
                 <a:solidFill>
                   <a:srgbClr val="AB3D3F"/>
                 </a:solidFill>
                 <a:latin typeface="Candara"/>
               </a:rPr>
-              <a:t>The rule</a:t>
+              <a:t>The rule, for each district i</a:t>
             </a:r>
           </a:p>
           <a:p>
             <a:pPr algn="l">
               <a:spcAft>
-                <a:spcPts val="1400"/>
+                <a:spcPts val="200"/>
               </a:spcAft>
             </a:pPr>
             <a:r>
-              <a:rPr sz="1400" b="0" i="0">
+              <a:rPr sz="1800" b="0" i="0">
                 <a:solidFill>
                   <a:srgbClr val="262626"/>
                 </a:solidFill>
-                <a:latin typeface="Candara"/>
-              </a:rPr>
-              <a:t>Weight = upper 95% bound of expected cases (negative binomial with a population offset) × (1 - net coverage). Hamilton's largest-remainder method turns the weights into exactly 50,000 whole nets.</a:t>
+                <a:latin typeface="Cambria Math"/>
+              </a:rPr>
+              <a:t>log μ</a:t>
+            </a:r>
+            <a:r>
+              <a:rPr baseline="-25000" sz="1800" b="0" i="0">
+                <a:solidFill>
+                  <a:srgbClr val="262626"/>
+                </a:solidFill>
+                <a:latin typeface="Cambria Math"/>
+              </a:rPr>
+              <a:t>i</a:t>
+            </a:r>
+            <a:r>
+              <a:rPr sz="1800" b="0" i="0">
+                <a:solidFill>
+                  <a:srgbClr val="262626"/>
+                </a:solidFill>
+                <a:latin typeface="Cambria Math"/>
+              </a:rPr>
+              <a:t> = log pop</a:t>
+            </a:r>
+            <a:r>
+              <a:rPr baseline="-25000" sz="1800" b="0" i="0">
+                <a:solidFill>
+                  <a:srgbClr val="262626"/>
+                </a:solidFill>
+                <a:latin typeface="Cambria Math"/>
+              </a:rPr>
+              <a:t>i</a:t>
+            </a:r>
+            <a:r>
+              <a:rPr sz="1800" b="0" i="0">
+                <a:solidFill>
+                  <a:srgbClr val="262626"/>
+                </a:solidFill>
+                <a:latin typeface="Cambria Math"/>
+              </a:rPr>
+              <a:t> + β</a:t>
+            </a:r>
+            <a:r>
+              <a:rPr baseline="-25000" sz="1800" b="0" i="0">
+                <a:solidFill>
+                  <a:srgbClr val="262626"/>
+                </a:solidFill>
+                <a:latin typeface="Cambria Math"/>
+              </a:rPr>
+              <a:t>0</a:t>
+            </a:r>
+            <a:r>
+              <a:rPr sz="1800" b="0" i="0">
+                <a:solidFill>
+                  <a:srgbClr val="262626"/>
+                </a:solidFill>
+                <a:latin typeface="Cambria Math"/>
+              </a:rPr>
+              <a:t> + β</a:t>
+            </a:r>
+            <a:r>
+              <a:rPr baseline="-25000" sz="1800" b="0" i="0">
+                <a:solidFill>
+                  <a:srgbClr val="262626"/>
+                </a:solidFill>
+                <a:latin typeface="Cambria Math"/>
+              </a:rPr>
+              <a:t>1</a:t>
+            </a:r>
+            <a:r>
+              <a:rPr sz="1800" b="0" i="0">
+                <a:solidFill>
+                  <a:srgbClr val="262626"/>
+                </a:solidFill>
+                <a:latin typeface="Cambria Math"/>
+              </a:rPr>
+              <a:t> c</a:t>
+            </a:r>
+            <a:r>
+              <a:rPr baseline="-25000" sz="1800" b="0" i="0">
+                <a:solidFill>
+                  <a:srgbClr val="262626"/>
+                </a:solidFill>
+                <a:latin typeface="Cambria Math"/>
+              </a:rPr>
+              <a:t>i</a:t>
+            </a:r>
+          </a:p>
+          <a:p>
+            <a:pPr algn="l">
+              <a:spcAft>
+                <a:spcPts val="200"/>
+              </a:spcAft>
+            </a:pPr>
+            <a:r>
+              <a:rPr sz="1800" b="0" i="0">
+                <a:solidFill>
+                  <a:srgbClr val="262626"/>
+                </a:solidFill>
+                <a:latin typeface="Cambria Math"/>
+              </a:rPr>
+              <a:t>w</a:t>
+            </a:r>
+            <a:r>
+              <a:rPr baseline="-25000" sz="1800" b="0" i="0">
+                <a:solidFill>
+                  <a:srgbClr val="262626"/>
+                </a:solidFill>
+                <a:latin typeface="Cambria Math"/>
+              </a:rPr>
+              <a:t>i</a:t>
+            </a:r>
+            <a:r>
+              <a:rPr sz="1800" b="0" i="0">
+                <a:solidFill>
+                  <a:srgbClr val="262626"/>
+                </a:solidFill>
+                <a:latin typeface="Cambria Math"/>
+              </a:rPr>
+              <a:t> = U</a:t>
+            </a:r>
+            <a:r>
+              <a:rPr baseline="-25000" sz="1800" b="0" i="0">
+                <a:solidFill>
+                  <a:srgbClr val="262626"/>
+                </a:solidFill>
+                <a:latin typeface="Cambria Math"/>
+              </a:rPr>
+              <a:t>i</a:t>
+            </a:r>
+            <a:r>
+              <a:rPr sz="1800" b="0" i="0">
+                <a:solidFill>
+                  <a:srgbClr val="262626"/>
+                </a:solidFill>
+                <a:latin typeface="Cambria Math"/>
+              </a:rPr>
+              <a:t> × (1 − c</a:t>
+            </a:r>
+            <a:r>
+              <a:rPr baseline="-25000" sz="1800" b="0" i="0">
+                <a:solidFill>
+                  <a:srgbClr val="262626"/>
+                </a:solidFill>
+                <a:latin typeface="Cambria Math"/>
+              </a:rPr>
+              <a:t>i</a:t>
+            </a:r>
+            <a:r>
+              <a:rPr sz="1800" b="0" i="0">
+                <a:solidFill>
+                  <a:srgbClr val="262626"/>
+                </a:solidFill>
+                <a:latin typeface="Cambria Math"/>
+              </a:rPr>
+              <a:t> / 100)</a:t>
+            </a:r>
+          </a:p>
+          <a:p>
+            <a:pPr algn="l">
+              <a:spcAft>
+                <a:spcPts val="600"/>
+              </a:spcAft>
+            </a:pPr>
+            <a:r>
+              <a:rPr sz="1500" b="0" i="0">
+                <a:solidFill>
+                  <a:srgbClr val="262626"/>
+                </a:solidFill>
+                <a:latin typeface="Cambria Math"/>
+              </a:rPr>
+              <a:t>q</a:t>
+            </a:r>
+            <a:r>
+              <a:rPr baseline="-25000" sz="1500" b="0" i="0">
+                <a:solidFill>
+                  <a:srgbClr val="262626"/>
+                </a:solidFill>
+                <a:latin typeface="Cambria Math"/>
+              </a:rPr>
+              <a:t>i</a:t>
+            </a:r>
+            <a:r>
+              <a:rPr sz="1500" b="0" i="0">
+                <a:solidFill>
+                  <a:srgbClr val="262626"/>
+                </a:solidFill>
+                <a:latin typeface="Cambria Math"/>
+              </a:rPr>
+              <a:t> = 50,000 × w</a:t>
+            </a:r>
+            <a:r>
+              <a:rPr baseline="-25000" sz="1500" b="0" i="0">
+                <a:solidFill>
+                  <a:srgbClr val="262626"/>
+                </a:solidFill>
+                <a:latin typeface="Cambria Math"/>
+              </a:rPr>
+              <a:t>i</a:t>
+            </a:r>
+            <a:r>
+              <a:rPr sz="1500" b="0" i="0">
+                <a:solidFill>
+                  <a:srgbClr val="262626"/>
+                </a:solidFill>
+                <a:latin typeface="Cambria Math"/>
+              </a:rPr>
+              <a:t> / Σ</a:t>
+            </a:r>
+            <a:r>
+              <a:rPr baseline="-25000" sz="1500" b="0" i="0">
+                <a:solidFill>
+                  <a:srgbClr val="262626"/>
+                </a:solidFill>
+                <a:latin typeface="Cambria Math"/>
+              </a:rPr>
+              <a:t>j</a:t>
+            </a:r>
+            <a:r>
+              <a:rPr sz="1500" b="0" i="0">
+                <a:solidFill>
+                  <a:srgbClr val="262626"/>
+                </a:solidFill>
+                <a:latin typeface="Cambria Math"/>
+              </a:rPr>
+              <a:t> w</a:t>
+            </a:r>
+            <a:r>
+              <a:rPr baseline="-25000" sz="1500" b="0" i="0">
+                <a:solidFill>
+                  <a:srgbClr val="262626"/>
+                </a:solidFill>
+                <a:latin typeface="Cambria Math"/>
+              </a:rPr>
+              <a:t>j</a:t>
+            </a:r>
+            <a:r>
+              <a:rPr sz="1500" b="0" i="0">
+                <a:solidFill>
+                  <a:srgbClr val="262626"/>
+                </a:solidFill>
+                <a:latin typeface="Cambria Math"/>
+              </a:rPr>
+              <a:t>,   A</a:t>
+            </a:r>
+            <a:r>
+              <a:rPr baseline="-25000" sz="1500" b="0" i="0">
+                <a:solidFill>
+                  <a:srgbClr val="262626"/>
+                </a:solidFill>
+                <a:latin typeface="Cambria Math"/>
+              </a:rPr>
+              <a:t>i</a:t>
+            </a:r>
+            <a:r>
+              <a:rPr sz="1500" b="0" i="0">
+                <a:solidFill>
+                  <a:srgbClr val="262626"/>
+                </a:solidFill>
+                <a:latin typeface="Cambria Math"/>
+              </a:rPr>
+              <a:t> = ⌊q</a:t>
+            </a:r>
+            <a:r>
+              <a:rPr baseline="-25000" sz="1500" b="0" i="0">
+                <a:solidFill>
+                  <a:srgbClr val="262626"/>
+                </a:solidFill>
+                <a:latin typeface="Cambria Math"/>
+              </a:rPr>
+              <a:t>i</a:t>
+            </a:r>
+            <a:r>
+              <a:rPr sz="1500" b="0" i="0">
+                <a:solidFill>
+                  <a:srgbClr val="262626"/>
+                </a:solidFill>
+                <a:latin typeface="Cambria Math"/>
+              </a:rPr>
+              <a:t>⌋ or ⌊q</a:t>
+            </a:r>
+            <a:r>
+              <a:rPr baseline="-25000" sz="1500" b="0" i="0">
+                <a:solidFill>
+                  <a:srgbClr val="262626"/>
+                </a:solidFill>
+                <a:latin typeface="Cambria Math"/>
+              </a:rPr>
+              <a:t>i</a:t>
+            </a:r>
+            <a:r>
+              <a:rPr sz="1500" b="0" i="0">
+                <a:solidFill>
+                  <a:srgbClr val="262626"/>
+                </a:solidFill>
+                <a:latin typeface="Cambria Math"/>
+              </a:rPr>
+              <a:t>⌋ + 1,   Σ</a:t>
+            </a:r>
+            <a:r>
+              <a:rPr baseline="-25000" sz="1500" b="0" i="0">
+                <a:solidFill>
+                  <a:srgbClr val="262626"/>
+                </a:solidFill>
+                <a:latin typeface="Cambria Math"/>
+              </a:rPr>
+              <a:t>i</a:t>
+            </a:r>
+            <a:r>
+              <a:rPr sz="1500" b="0" i="0">
+                <a:solidFill>
+                  <a:srgbClr val="262626"/>
+                </a:solidFill>
+                <a:latin typeface="Cambria Math"/>
+              </a:rPr>
+              <a:t> A</a:t>
+            </a:r>
+            <a:r>
+              <a:rPr baseline="-25000" sz="1500" b="0" i="0">
+                <a:solidFill>
+                  <a:srgbClr val="262626"/>
+                </a:solidFill>
+                <a:latin typeface="Cambria Math"/>
+              </a:rPr>
+              <a:t>i</a:t>
+            </a:r>
+            <a:r>
+              <a:rPr sz="1500" b="0" i="0">
+                <a:solidFill>
+                  <a:srgbClr val="262626"/>
+                </a:solidFill>
+                <a:latin typeface="Cambria Math"/>
+              </a:rPr>
+              <a:t> = 50,000</a:t>
+            </a:r>
+          </a:p>
+          <a:p>
+            <a:pPr algn="l">
+              <a:spcAft>
+                <a:spcPts val="1000"/>
+              </a:spcAft>
+            </a:pPr>
+            <a:r>
+              <a:rPr sz="1150" b="0" i="0">
+                <a:solidFill>
+                  <a:srgbClr val="595959"/>
+                </a:solidFill>
+                <a:latin typeface="Candara"/>
+              </a:rPr>
+              <a:t>Unit: district i. Target: μ</a:t>
+            </a:r>
+            <a:r>
+              <a:rPr baseline="-25000" sz="1150" b="0" i="0">
+                <a:solidFill>
+                  <a:srgbClr val="595959"/>
+                </a:solidFill>
+                <a:latin typeface="Candara"/>
+              </a:rPr>
+              <a:t>i</a:t>
+            </a:r>
+            <a:r>
+              <a:rPr sz="1150" b="0" i="0">
+                <a:solidFill>
+                  <a:srgbClr val="595959"/>
+                </a:solidFill>
+                <a:latin typeface="Candara"/>
+              </a:rPr>
+              <a:t>, expected confirmed cases 2014-17, from a negative binomial (variance μ</a:t>
+            </a:r>
+            <a:r>
+              <a:rPr baseline="-25000" sz="1150" b="0" i="0">
+                <a:solidFill>
+                  <a:srgbClr val="595959"/>
+                </a:solidFill>
+                <a:latin typeface="Candara"/>
+              </a:rPr>
+              <a:t>i</a:t>
+            </a:r>
+            <a:r>
+              <a:rPr sz="1150" b="0" i="0">
+                <a:solidFill>
+                  <a:srgbClr val="595959"/>
+                </a:solidFill>
+                <a:latin typeface="Candara"/>
+              </a:rPr>
+              <a:t> + αμ</a:t>
+            </a:r>
+            <a:r>
+              <a:rPr baseline="-25000" sz="1150" b="0" i="0">
+                <a:solidFill>
+                  <a:srgbClr val="595959"/>
+                </a:solidFill>
+                <a:latin typeface="Candara"/>
+              </a:rPr>
+              <a:t>i</a:t>
+            </a:r>
+            <a:r>
+              <a:rPr sz="1150" b="0" i="0">
+                <a:solidFill>
+                  <a:srgbClr val="595959"/>
+                </a:solidFill>
+                <a:latin typeface="Candara"/>
+              </a:rPr>
+              <a:t>², α = 0.268). Metric: the weight w</a:t>
+            </a:r>
+            <a:r>
+              <a:rPr baseline="-25000" sz="1150" b="0" i="0">
+                <a:solidFill>
+                  <a:srgbClr val="595959"/>
+                </a:solidFill>
+                <a:latin typeface="Candara"/>
+              </a:rPr>
+              <a:t>i</a:t>
+            </a:r>
+            <a:r>
+              <a:rPr sz="1150" b="0" i="0">
+                <a:solidFill>
+                  <a:srgbClr val="595959"/>
+                </a:solidFill>
+                <a:latin typeface="Candara"/>
+              </a:rPr>
+              <a:t>. U</a:t>
+            </a:r>
+            <a:r>
+              <a:rPr baseline="-25000" sz="1150" b="0" i="0">
+                <a:solidFill>
+                  <a:srgbClr val="595959"/>
+                </a:solidFill>
+                <a:latin typeface="Candara"/>
+              </a:rPr>
+              <a:t>i</a:t>
+            </a:r>
+            <a:r>
+              <a:rPr sz="1150" b="0" i="0">
+                <a:solidFill>
+                  <a:srgbClr val="595959"/>
+                </a:solidFill>
+                <a:latin typeface="Candara"/>
+              </a:rPr>
+              <a:t>: upper 95% confidence bound for μ</a:t>
+            </a:r>
+            <a:r>
+              <a:rPr baseline="-25000" sz="1150" b="0" i="0">
+                <a:solidFill>
+                  <a:srgbClr val="595959"/>
+                </a:solidFill>
+                <a:latin typeface="Candara"/>
+              </a:rPr>
+              <a:t>i</a:t>
+            </a:r>
+            <a:r>
+              <a:rPr sz="1150" b="0" i="0">
+                <a:solidFill>
+                  <a:srgbClr val="595959"/>
+                </a:solidFill>
+                <a:latin typeface="Candara"/>
+              </a:rPr>
+              <a:t>. c</a:t>
+            </a:r>
+            <a:r>
+              <a:rPr baseline="-25000" sz="1150" b="0" i="0">
+                <a:solidFill>
+                  <a:srgbClr val="595959"/>
+                </a:solidFill>
+                <a:latin typeface="Candara"/>
+              </a:rPr>
+              <a:t>i</a:t>
+            </a:r>
+            <a:r>
+              <a:rPr sz="1150" b="0" i="0">
+                <a:solidFill>
+                  <a:srgbClr val="595959"/>
+                </a:solidFill>
+                <a:latin typeface="Candara"/>
+              </a:rPr>
+              <a:t>: % of homes with a net in i's region. A</a:t>
+            </a:r>
+            <a:r>
+              <a:rPr baseline="-25000" sz="1150" b="0" i="0">
+                <a:solidFill>
+                  <a:srgbClr val="595959"/>
+                </a:solidFill>
+                <a:latin typeface="Candara"/>
+              </a:rPr>
+              <a:t>i</a:t>
+            </a:r>
+            <a:r>
+              <a:rPr sz="1150" b="0" i="0">
+                <a:solidFill>
+                  <a:srgbClr val="595959"/>
+                </a:solidFill>
+                <a:latin typeface="Candara"/>
+              </a:rPr>
+              <a:t>: nets, by Hamilton's largest-remainder method.</a:t>
             </a:r>
           </a:p>
           <a:p>
@@ -7987,55 +8481,13 @@
               </a:spcAft>
             </a:pPr>
             <a:r>
-              <a:rPr sz="1800" b="1" i="0">
+              <a:rPr sz="1700" b="1" i="0">
                 <a:solidFill>
                   <a:srgbClr val="AB3D3F"/>
                 </a:solidFill>
                 <a:latin typeface="Candara"/>
               </a:rPr>
-              <a:t>What it does in practice</a:t>
-            </a:r>
-          </a:p>
-          <a:p>
-            <a:pPr algn="l" marL="219456" indent="-219456">
-              <a:spcAft>
-                <a:spcPts val="800"/>
-              </a:spcAft>
-              <a:buClr>
-                <a:srgbClr val="AB3D3F"/>
-              </a:buClr>
-              <a:buFont typeface="Arial"/>
-              <a:buChar char="•"/>
-            </a:pPr>
-            <a:r>
-              <a:rPr sz="1400" b="0" i="0">
-                <a:solidFill>
-                  <a:srgbClr val="262626"/>
-                </a:solidFill>
-                <a:latin typeface="Candara"/>
-              </a:rPr>
-              <a:t>Coverage is one number per region, so expected cases are population times a regional rate. Within a region, nets follow population exactly.</a:t>
-            </a:r>
-          </a:p>
-          <a:p>
-            <a:pPr algn="l" marL="219456" indent="-219456">
-              <a:spcAft>
-                <a:spcPts val="800"/>
-              </a:spcAft>
-              <a:buClr>
-                <a:srgbClr val="AB3D3F"/>
-              </a:buClr>
-              <a:buFont typeface="Arial"/>
-              <a:buChar char="•"/>
-            </a:pPr>
-            <a:r>
-              <a:rPr sz="1400" b="0" i="0">
-                <a:solidFill>
-                  <a:srgbClr val="262626"/>
-                </a:solidFill>
-                <a:latin typeface="Candara"/>
-              </a:rPr>
-              <a:t>The upper bound is a confidence interval for the mean, not a prediction interval. It adds one multiplier per region: 1.20, 1.34 and 1.16.</a:t>
+              <a:t>What it does with our data</a:t>
             </a:r>
           </a:p>
           <a:p>
@@ -8050,13 +8502,127 @@
               <a:buChar char="•"/>
             </a:pPr>
             <a:r>
-              <a:rPr sz="1400" b="0" i="0">
+              <a:rPr sz="1300" b="0" i="0">
                 <a:solidFill>
                   <a:srgbClr val="262626"/>
                 </a:solidFill>
                 <a:latin typeface="Candara"/>
               </a:rPr>
-              <a:t>The coverage coefficient is positive (+0.082 per point): regions with more nets had more malaria. So higher coverage earns more nets per person.</a:t>
+              <a:t>c</a:t>
+            </a:r>
+            <a:r>
+              <a:rPr baseline="-25000" sz="1300" b="0" i="0">
+                <a:solidFill>
+                  <a:srgbClr val="262626"/>
+                </a:solidFill>
+                <a:latin typeface="Candara"/>
+              </a:rPr>
+              <a:t>i</a:t>
+            </a:r>
+            <a:r>
+              <a:rPr sz="1300" b="0" i="0">
+                <a:solidFill>
+                  <a:srgbClr val="262626"/>
+                </a:solidFill>
+                <a:latin typeface="Candara"/>
+              </a:rPr>
+              <a:t> takes one value per region, so inside a region nets follow population: 8.5, 16.0 and 9.2 per 1,000 people.</a:t>
+            </a:r>
+          </a:p>
+          <a:p>
+            <a:pPr algn="l" marL="219456" indent="-219456">
+              <a:spcAft>
+                <a:spcPts val="600"/>
+              </a:spcAft>
+              <a:buClr>
+                <a:srgbClr val="AB3D3F"/>
+              </a:buClr>
+              <a:buFont typeface="Arial"/>
+              <a:buChar char="•"/>
+            </a:pPr>
+            <a:r>
+              <a:rPr sz="1300" b="0" i="0">
+                <a:solidFill>
+                  <a:srgbClr val="262626"/>
+                </a:solidFill>
+                <a:latin typeface="Candara"/>
+              </a:rPr>
+              <a:t>U</a:t>
+            </a:r>
+            <a:r>
+              <a:rPr baseline="-25000" sz="1300" b="0" i="0">
+                <a:solidFill>
+                  <a:srgbClr val="262626"/>
+                </a:solidFill>
+                <a:latin typeface="Candara"/>
+              </a:rPr>
+              <a:t>i</a:t>
+            </a:r>
+            <a:r>
+              <a:rPr sz="1300" b="0" i="0">
+                <a:solidFill>
+                  <a:srgbClr val="262626"/>
+                </a:solidFill>
+                <a:latin typeface="Candara"/>
+              </a:rPr>
+              <a:t> = μ</a:t>
+            </a:r>
+            <a:r>
+              <a:rPr baseline="-25000" sz="1300" b="0" i="0">
+                <a:solidFill>
+                  <a:srgbClr val="262626"/>
+                </a:solidFill>
+                <a:latin typeface="Candara"/>
+              </a:rPr>
+              <a:t>i</a:t>
+            </a:r>
+            <a:r>
+              <a:rPr sz="1300" b="0" i="0">
+                <a:solidFill>
+                  <a:srgbClr val="262626"/>
+                </a:solidFill>
+                <a:latin typeface="Candara"/>
+              </a:rPr>
+              <a:t> × 1.20, 1.34 or 1.16: one multiplier per region, from a confidence interval for the mean.</a:t>
+            </a:r>
+          </a:p>
+          <a:p>
+            <a:pPr algn="l" marL="219456" indent="-219456">
+              <a:spcAft>
+                <a:spcPts val="600"/>
+              </a:spcAft>
+              <a:buClr>
+                <a:srgbClr val="AB3D3F"/>
+              </a:buClr>
+              <a:buFont typeface="Arial"/>
+              <a:buChar char="•"/>
+            </a:pPr>
+            <a:r>
+              <a:rPr sz="1300" b="0" i="0">
+                <a:solidFill>
+                  <a:srgbClr val="262626"/>
+                </a:solidFill>
+                <a:latin typeface="Candara"/>
+              </a:rPr>
+              <a:t>β</a:t>
+            </a:r>
+            <a:r>
+              <a:rPr baseline="-25000" sz="1300" b="0" i="0">
+                <a:solidFill>
+                  <a:srgbClr val="262626"/>
+                </a:solidFill>
+                <a:latin typeface="Candara"/>
+              </a:rPr>
+              <a:t>1</a:t>
+            </a:r>
+            <a:r>
+              <a:rPr sz="1300" b="0" i="0">
+                <a:solidFill>
+                  <a:srgbClr val="262626"/>
+                </a:solidFill>
+                <a:latin typeface="Candara"/>
+              </a:rPr>
+              <a:t> = +0.082 per point: more nets went with more malaria, so the split between regions is uncertain.</a:t>
             </a:r>
           </a:p>
         </p:txBody>
@@ -8070,8 +8636,8 @@
           <p:nvPr/>
         </p:nvGraphicFramePr>
         <p:xfrm>
-          <a:off x="6400800" y="1417320"/>
-          <a:ext cx="5212080" cy="3840480"/>
+          <a:off x="7040880" y="1417320"/>
+          <a:ext cx="4572000" cy="3840480"/>
         </p:xfrm>
         <a:graphic>
           <a:graphicData uri="http://schemas.openxmlformats.org/drawingml/2006/chart">
@@ -8087,8 +8653,8 @@
         </p:nvSpPr>
         <p:spPr>
           <a:xfrm>
-            <a:off x="6400800" y="5303520"/>
-            <a:ext cx="5212080" cy="502920"/>
+            <a:off x="7040880" y="5303520"/>
+            <a:ext cx="4572000" cy="548640"/>
           </a:xfrm>
           <a:prstGeom prst="rect">
             <a:avLst/>

</xml_diff>

<commit_message>
feat(presentation): keep only sources in the speaker notes
The deck will be submitted, so the notes drop the spoken talk track and presenter reminders and keep each slide's sources, which the brief's checklist asks for. Slide 14's notes no longer contain a path into data/.
</commit_message>
<xml_diff>
--- a/reports/ITN_Allocation_Ashesi.pptx
+++ b/reports/ITN_Allocation_Ashesi.pptx
@@ -1252,12 +1252,12 @@
           <a:lstStyle/>
           <a:p>
             <a:r>
-              <a:t>Say: Stratifying by region keeps every region in both training and test, so neighbours still leak. Only holding a whole region out tests what the model does somewhere new, and the error roughly quadruples.</a:t>
-            </a:r>
-          </a:p>
-          <a:p>
-            <a:r>
-              <a:t>Sources: notebooks/03_pipeline_leakage.ipynb, cells leak_cd12 (500 seeds) and leak_cd14 (whole region held out, via io.split_data(..., hold_out=region)). Literature: Ploton et al. 2020, Nature Communications 11:4540, doi:10.1038/s41467-020-18321-y; Kattenborn et al. 2022, ISPRS Open Journal of Photogrammetry and Remote Sensing, doi:10.1016/j.ophoto.2022.100018 (up to 28% overestimation of F1-score).</a:t>
+              <a:t>Symbols: i = district (the unit); mu_i = expected confirmed cases, 2014-17 (the target); w_i = allocation weight (the metric); pop_i = population; c_i = % of homes owning a net in i's region (DHS 2022); U_i = upper 95% confidence bound for mu_i; q_i = exact share; A_i = nets.</a:t>
+            </a:r>
+          </a:p>
+          <a:p>
+            <a:r>
+              <a:t>Sources: notebooks/04_allocation.ipynb cells alloc_cd05 (alpha 0.2677) and alloc_cd11 (beta_1 = +0.0823, p = 1.7e-07; U_i / mu_i = 1.198, 1.342, 1.162; nets per 1,000 people); src/models.py compute_allocation and hamilton. Coverage values: notebooks/02 cell cd06 and scripts/verify_claims.py section D.</a:t>
             </a:r>
           </a:p>
         </p:txBody>
@@ -1327,17 +1327,7 @@
           <a:lstStyle/>
           <a:p>
             <a:r>
-              <a:t>Say: The slide writes the rule as math; say it in words. Line one: expected confirmed cases grow in proportion to population and depend on the region's net coverage (a negative binomial model with a population offset). Line two: each district's weight is the cautious upper end of its expected cases times the share of homes without a net. Line three: Hamilton's largest-remainder method turns the weights into exactly 50,000 whole nets. Then: because coverage is one number per region, inside a region nets follow population; the upper bound adds one multiplier per region; and the coverage coefficient is positive because nets went where malaria was worst, so the split between regions is uncertain.</a:t>
-            </a:r>
-          </a:p>
-          <a:p>
-            <a:r>
-              <a:t>Symbols: i = district (the unit); mu_i = expected confirmed cases, 2014-17 (the target); w_i = allocation weight (the metric); pop_i = population; c_i = % of homes owning a net in i's region (DHS 2022); U_i = upper 95% confidence bound for mu_i; q_i = exact share; A_i = nets.</a:t>
-            </a:r>
-          </a:p>
-          <a:p>
-            <a:r>
-              <a:t>Sources: notebooks/04_allocation.ipynb cells alloc_cd05 (alpha 0.2677) and alloc_cd11 (beta_1 = +0.0823, p = 1.7e-07; U_i / mu_i = 1.198, 1.342, 1.162; nets per 1,000 people); src/models.py compute_allocation and hamilton. Coverage values: notebooks/02 cell cd06 and scripts/verify_claims.py section D.</a:t>
+              <a:t>Sources: cases per person and the upper-to-expected ratios 1.198, 1.342 and 1.162: notebooks/04_allocation.ipynb cell alloc_cd11. Both maps are drawn with src/viz.plot_district_choropleth from models.compute_allocation, zoomed to the north like the allocation map. The two-map layout (burden next to uncertainty) follows the course roadmap.</a:t>
             </a:r>
           </a:p>
         </p:txBody>
@@ -1407,12 +1397,7 @@
           <a:lstStyle/>
           <a:p>
             <a:r>
-              <a:t>Say: The left map shows reported burden: confirmed cases per person over 2014-17. It is highest in Upper East and Upper West and lowest across Northern Region, where the test data point to under-testing. The right map shows how sure we are: the upper end of our 95% interval sits 20% above the estimate in Northern, 34% in Upper East and 16% in Upper West. It is one number per region because coverage is. Our rule uses that upper bound, so it leans towards the region we are least sure about.</a:t>
-            </a:r>
-          </a:p>
-          <a:p>
-            <a:r>
-              <a:t>Sources: cases per person and the upper-to-expected ratios 1.198, 1.342 and 1.162: notebooks/04_allocation.ipynb cell alloc_cd11. Both maps are drawn with src/viz.plot_district_choropleth from models.compute_allocation, zoomed to the north like the allocation map. The two-map layout (burden next to uncertainty) follows the course roadmap.</a:t>
+              <a:t>Sources: the 50-district schedule in reports/allocation.md reproduces exactly from notebooks/04_allocation.ipynb (cells alloc_cd07 and alloc_cd09; scripts/verify_claims.py section C checks all 50 rows). Map drawn with src/viz.plot_district_choropleth from the same allocation, zoomed to the north. The three pre-2018 districts later split (Garu-Tempane, Savelugu-Nanton, Bunkpurugu-Yunyoo) show their total on both successor areas.</a:t>
             </a:r>
           </a:p>
         </p:txBody>
@@ -1482,12 +1467,7 @@
           <a:lstStyle/>
           <a:p>
             <a:r>
-              <a:t>Say: This is the allocation our current rule produces.</a:t>
-            </a:r>
-          </a:p>
-          <a:p>
-            <a:r>
-              <a:t>Sources: the 50-district schedule in reports/allocation.md reproduces exactly from notebooks/04_allocation.ipynb (cells alloc_cd07 and alloc_cd09; scripts/verify_claims.py section C checks all 50 rows). Map drawn with src/viz.plot_district_choropleth from the same allocation, zoomed to the north. The three pre-2018 districts later split (Garu-Tempane, Savelugu-Nanton, Bunkpurugu-Yunyoo) show their total on both successor areas.</a:t>
+              <a:t>Sources: gains and losses: notebooks/04_allocation.ipynb alloc_cd09; cases-per-person ranks: alloc_cd11 (Tamale lowest of 50, Nabdam highest of 50, Bole highest in its region). Ghana's ITN strategy: PMI Ghana Malaria Operational Plan FY2017. Tamale Teaching Hospital as the only tertiary provider for the three northern regions: https://tth.gov.gh/about</a:t>
             </a:r>
           </a:p>
         </p:txBody>
@@ -1557,12 +1537,7 @@
           <a:lstStyle/>
           <a:p>
             <a:r>
-              <a:t>Say: Against a case-proportional comparator, nets move from districts with high reported cases per person to populous districts. That follows from treating everyone in a region as equally at risk. Referral bias may exist, but our data do not show it: Bolgatanga ranks only 4th of 13 in Upper East on cases per person, and Nabdam, often named as a sending district, ranks 1st.</a:t>
-            </a:r>
-          </a:p>
-          <a:p>
-            <a:r>
-              <a:t>Sources: gains and losses: notebooks/04_allocation.ipynb alloc_cd09; cases-per-person ranks: alloc_cd11 (Tamale lowest of 50, Nabdam highest of 50, Bole highest in its region). Ghana's ITN strategy: PMI Ghana Malaria Operational Plan FY2017. Tamale Teaching Hospital as the only tertiary provider for the three northern regions: https://tth.gov.gh/about</a:t>
+              <a:t>Sources: notebooks/04_allocation.ipynb cell alloc_cd13, which also prints the coverage it uses (Savannah 79.1%, North East 62.8%; published 79.1% and 62.6%, GDHS 2022 Table 12.1) and the Northern cluster-bootstrap bounds 61.4% and 74.0% (as in notebooks/02 cell cd39).</a:t>
             </a:r>
           </a:p>
         </p:txBody>
@@ -1632,12 +1607,7 @@
           <a:lstStyle/>
           <a:p>
             <a:r>
-              <a:t>Say: This is where we volunteer our weak points. A region-effects model, which fits the data better, moves 7,720 nets. Correcting the coverage of 11 districts moves 3,740. Lowering Northern Region's coverage gives it fewer nets, not more, because of the positive coverage coefficient.</a:t>
-            </a:r>
-          </a:p>
-          <a:p>
-            <a:r>
-              <a:t>Sources: notebooks/04_allocation.ipynb cell alloc_cd13, which also prints the coverage it uses (Savannah 79.1%, North East 62.8%; published 79.1% and 62.6%, GDHS 2022 Table 12.1) and the Northern cluster-bootstrap bounds 61.4% and 74.0% (as in notebooks/02 cell cd39).</a:t>
+              <a:t>Sources: 207 of 260 districts: scripts/verify_claims.py (map join). Test positivity and cases per person by region: scripts/verify_claims.py section E. Spraying and chemoprevention counts: scripts/verify_claims.py section E, from the raw surveillance workbook in the course data package (these columns are not in the curated district file). Campaign rules: PMI Ghana Malaria Operational Plan FY2017. Privacy: git history holds no data files and no notebook outputs (checked 2026-09-22).</a:t>
             </a:r>
           </a:p>
         </p:txBody>
@@ -1707,12 +1677,7 @@
           <a:lstStyle/>
           <a:p>
             <a:r>
-              <a:t>Say: Equity is about who the rule helps and who it cannot see.</a:t>
-            </a:r>
-          </a:p>
-          <a:p>
-            <a:r>
-              <a:t>Sources: 207 of 260 districts: scripts/verify_claims.py (map join). Test positivity and cases per person by region: scripts/verify_claims.py section E. Spraying and chemoprevention counts: scripts/verify_claims.py section E, from data/raw/northern-ghana-districts-routine-data-2014-17.xlsx (these columns are not in ghana_district_cases.csv). Campaign rules: PMI Ghana Malaria Operational Plan FY2017. Privacy: git history holds no data files and no notebook outputs (checked 2026-09-22).</a:t>
+              <a:t>Sources: 11 districts, 3,740 nets, 79.1% and 62.8%: notebooks/04_allocation.ipynb alloc_cd13. 39 of 50 districts: scripts/verify_claims.py section E. Empty ITN intervals: notebooks/02 cell cd37. No district identifier or parasitaemia: notebooks/02 cell cd06.</a:t>
             </a:r>
           </a:p>
         </p:txBody>
@@ -1782,86 +1747,6 @@
           <a:lstStyle/>
           <a:p>
             <a:r>
-              <a:t>Say: These are the limits we know about, and what we would do before any real distribution.</a:t>
-            </a:r>
-          </a:p>
-          <a:p>
-            <a:r>
-              <a:t>Sources: 11 districts, 3,740 nets, 79.1% and 62.8%: notebooks/04_allocation.ipynb alloc_cd13. 39 of 50 districts: scripts/verify_claims.py section E. Empty ITN intervals: notebooks/02 cell cd37. No district identifier or parasitaemia: notebooks/02 cell cd06.</a:t>
-            </a:r>
-          </a:p>
-        </p:txBody>
-      </p:sp>
-      <p:sp>
-        <p:nvSpPr>
-          <p:cNvPr id="4" name="Slide Number Placeholder 3"/>
-          <p:cNvSpPr>
-            <a:spLocks noGrp="1"/>
-          </p:cNvSpPr>
-          <p:nvPr>
-            <p:ph type="sldNum" idx="5" sz="quarter"/>
-          </p:nvPr>
-        </p:nvSpPr>
-        <p:spPr/>
-      </p:sp>
-    </p:spTree>
-  </p:cSld>
-  <p:clrMapOvr>
-    <a:masterClrMapping/>
-  </p:clrMapOvr>
-</p:notes>
-</file>
-
-<file path=ppt/notesSlides/notesSlide18.xml><?xml version="1.0" encoding="utf-8"?>
-<p:notes xmlns:a="http://schemas.openxmlformats.org/drawingml/2006/main" xmlns:p="http://schemas.openxmlformats.org/presentationml/2006/main" xmlns:r="http://schemas.openxmlformats.org/officeDocument/2006/relationships">
-  <p:cSld>
-    <p:spTree>
-      <p:nvGrpSpPr>
-        <p:cNvPr id="1" name=""/>
-        <p:cNvGrpSpPr/>
-        <p:nvPr/>
-      </p:nvGrpSpPr>
-      <p:grpSpPr>
-        <a:xfrm>
-          <a:off x="0" y="0"/>
-          <a:ext cx="0" cy="0"/>
-          <a:chOff x="0" y="0"/>
-          <a:chExt cx="0" cy="0"/>
-        </a:xfrm>
-      </p:grpSpPr>
-      <p:sp>
-        <p:nvSpPr>
-          <p:cNvPr id="2" name="Slide Image Placeholder 1"/>
-          <p:cNvSpPr>
-            <a:spLocks noGrp="1"/>
-          </p:cNvSpPr>
-          <p:nvPr>
-            <p:ph type="sldImg" idx="2"/>
-          </p:nvPr>
-        </p:nvSpPr>
-        <p:spPr/>
-      </p:sp>
-      <p:sp>
-        <p:nvSpPr>
-          <p:cNvPr id="3" name="Notes Placeholder 2"/>
-          <p:cNvSpPr>
-            <a:spLocks noGrp="1"/>
-          </p:cNvSpPr>
-          <p:nvPr>
-            <p:ph type="body" idx="3" sz="quarter"/>
-          </p:nvPr>
-        </p:nvSpPr>
-        <p:spPr/>
-        <p:txBody>
-          <a:bodyPr/>
-          <a:lstStyle/>
-          <a:p>
-            <a:r>
-              <a:t>Say: Thank you. Every number in this deck has its source in the speaker notes; we are happy to take questions on any of them.</a:t>
-            </a:r>
-          </a:p>
-          <a:p>
-            <a:r>
               <a:t>The footnote is the group's AI declaration. Each member's own AI-use declaration is part of their individual reflection.</a:t>
             </a:r>
           </a:p>
@@ -1932,12 +1817,7 @@
           <a:lstStyle/>
           <a:p>
             <a:r>
-              <a:t>Say: We were asked where a limited delivery of 50,000 insecticide-treated nets should go across northern Ghana, and how confident we can be in the district numbers behind that choice. We start with our recommendation, then show the evidence and its limits.</a:t>
-            </a:r>
-          </a:p>
-          <a:p>
-            <a:r>
-              <a:t>Add the presenters' names to this slide before the panel.</a:t>
+              <a:t>Sources: notebooks/04_allocation.ipynb, cell alloc_cd07 (regional totals), alloc_cd11 (nets per 1,000 people) and alloc_cd13 (7,720 nets moved under the region-effects model).</a:t>
             </a:r>
           </a:p>
         </p:txBody>
@@ -2007,12 +1887,7 @@
           <a:lstStyle/>
           <a:p>
             <a:r>
-              <a:t>Say: Within each region the rule allocates in proportion to population, because coverage is measured once per region. The regional totals come from our negative binomial model and are our base case; be upfront that the regional split depends on the model.</a:t>
-            </a:r>
-          </a:p>
-          <a:p>
-            <a:r>
-              <a:t>Sources: notebooks/04_allocation.ipynb, cell alloc_cd07 (regional totals), alloc_cd11 (nets per 1,000 people) and alloc_cd13 (7,720 nets moved under the region-effects model).</a:t>
+              <a:t>Sources: Oppong et al., Malaria Journal, doi:10.1186/s12936-025-05724-9 (https://pmc.ncbi.nlm.nih.gov/articles/PMC12829291/); Ghana DHS 2022 final report FR387, Table 12.15.</a:t>
             </a:r>
           </a:p>
         </p:txBody>
@@ -2082,12 +1957,7 @@
           <a:lstStyle/>
           <a:p>
             <a:r>
-              <a:t>Say: This is why district detail matters. Be careful with the wording: the 49% is a model prediction for children aged 6 months to 10 years, and its highest values fall in forest areas, not slums. The 2% is the 2022 DHS microscopy figure for children under five (3.4% by rapid test).</a:t>
-            </a:r>
-          </a:p>
-          <a:p>
-            <a:r>
-              <a:t>Sources: Oppong et al., Malaria Journal, doi:10.1186/s12936-025-05724-9 (https://pmc.ncbi.nlm.nih.gov/articles/PMC12829291/); Ghana DHS 2022 final report FR387, Table 12.15.</a:t>
+              <a:t>Sources: 17,933 households and 618 clusters: data dictionary and notebooks/02 cell cd03. 71.0% vs 66.8% (claim C-01): notebooks/01_eda.ipynb cell eda_cd05. 50 districts on 53 polygons, 207 of 260 districts without data: scripts/verify_claims.py (map join, same logic as src/viz.py). Maps: figures/b1_data_availability.png and figures/b1_district_case_rate.png from notebook 01, with their titles trimmed.</a:t>
             </a:r>
           </a:p>
         </p:txBody>
@@ -2157,12 +2027,7 @@
           <a:lstStyle/>
           <a:p>
             <a:r>
-              <a:t>Say: We have two very different sources. The survey is representative but only resolves to region; the surveillance has district detail but only for the north.</a:t>
-            </a:r>
-          </a:p>
-          <a:p>
-            <a:r>
-              <a:t>Sources: 17,933 households and 618 clusters: data dictionary and notebooks/02 cell cd03. 71.0% vs 66.8% (claim C-01): notebooks/01_eda.ipynb cell eda_cd05. 50 districts on 53 polygons, 207 of 260 districts without data: scripts/verify_claims.py (map join, same logic as src/viz.py). Maps: figures/b1_data_availability.png and figures/b1_district_case_rate.png from notebook 01, with their titles trimmed.</a:t>
+              <a:t>Sources: notebooks/02_distributions.ipynb cells cd09 (77,183), cd15 (442, 122,882, 278 times), cd18 (0.395), cd25 and cd26 (54,147; alpha 0.2677; AIC gap 2,393,669). Figure: figures/a3_poisson_vs_nb.png, title trimmed.</a:t>
             </a:r>
           </a:p>
         </p:txBody>
@@ -2232,12 +2097,7 @@
           <a:lstStyle/>
           <a:p>
             <a:r>
-              <a:t>Say: Under a Poisson model the variance equals the mean. Here the variance is 77,183 times the mean, and even after adjusting for population the dispersion ratio is 54,147. The negative binomial adds one dispersion parameter and fits far better. The figure's curves use no covariates (alpha 0.395); the model we use has a population offset (alpha 0.268).</a:t>
-            </a:r>
-          </a:p>
-          <a:p>
-            <a:r>
-              <a:t>Sources: notebooks/02_distributions.ipynb cells cd09 (77,183), cd15 (442, 122,882, 278 times), cd18 (0.395), cd25 and cd26 (54,147; alpha 0.2677; AIC gap 2,393,669). Figure: figures/a3_poisson_vs_nb.png, title trimmed.</a:t>
+              <a:t>Sources: notebooks/02_distributions.ipynb cells cd31 (582 households, 20 clusters), cd33 and cd34 (15.20 vs 7.17, 2.12 times, design effect 4.50), cd37 (published ITN intervals empty, 0 of 76), cd39 (67.69% vs 67.6%). Seed spread 4.46 to 5.39 and design-based 4.18: scripts/verify_claims.py section A. Rank 10th of 16: scripts/verify_claims.py section D. Figure: figures/a4_bootstrap_ci_comparison.png, title trimmed.</a:t>
             </a:r>
           </a:p>
         </p:txBody>
@@ -2307,12 +2167,7 @@
           <a:lstStyle/>
           <a:p>
             <a:r>
-              <a:t>Say: The survey samples clusters, then households. Resampling households alone pretends each is independent and gives an interval half as wide as it should be.</a:t>
-            </a:r>
-          </a:p>
-          <a:p>
-            <a:r>
-              <a:t>Sources: notebooks/02_distributions.ipynb cells cd31 (582 households, 20 clusters), cd33 and cd34 (15.20 vs 7.17, 2.12 times, design effect 4.50), cd37 (published ITN intervals empty, 0 of 76), cd39 (67.69% vs 67.6%). Seed spread 4.46 to 5.39 and design-based 4.18: scripts/verify_claims.py section A. Rank 10th of 16: scripts/verify_claims.py section D. Figure: figures/a4_bootstrap_ci_comparison.png, title trimmed.</a:t>
+              <a:t>Sources: notebooks/03_pipeline_leakage.ipynb cells leak_cd04 (87,144 vs 87,356), leak_cd06 (R² 1.0000 vs 0.2618), leak_cd08 (one seed), leak_cd12 (500 seeds) and leak_cd14 (whole region held out); the table itself is leak_cd10.</a:t>
             </a:r>
           </a:p>
         </p:txBody>
@@ -2382,12 +2237,7 @@
           <a:lstStyle/>
           <a:p>
             <a:r>
-              <a:t>Say: We built each leak deliberately and compared it with the disciplined version. The spatial one needed a different test from the one we first used: comparing a random split with a stratified split at a single seed compares two different random test sets, and across seeds the difference disappears.</a:t>
-            </a:r>
-          </a:p>
-          <a:p>
-            <a:r>
-              <a:t>Sources: notebooks/03_pipeline_leakage.ipynb cells leak_cd04 (87,144 vs 87,356), leak_cd06 (R² 1.0000 vs 0.2618), leak_cd08 (one seed), leak_cd12 (500 seeds) and leak_cd14 (whole region held out); the table itself is leak_cd10.</a:t>
+              <a:t>Sources: notebooks/03_pipeline_leakage.ipynb, cells leak_cd12 (500 seeds) and leak_cd14 (whole region held out, via io.split_data(..., hold_out=region)). Literature: Ploton et al. 2020, Nature Communications 11:4540, doi:10.1038/s41467-020-18321-y; Kattenborn et al. 2022, ISPRS Open Journal of Photogrammetry and Remote Sensing, doi:10.1016/j.ophoto.2022.100018 (up to 28% overestimation of F1-score).</a:t>
             </a:r>
           </a:p>
         </p:txBody>

</xml_diff>